<commit_message>
Make the website link on the thank-you slide clickable in the PPTX
Each slide is a picture, so slide 8 gets a clear hyperlink area over the
printed address.

Co-Authored-By: Claude Opus 5.5 <noreply@anthropic.com>
</commit_message>
<xml_diff>
--- a/docs/files/final-presentation.pptx
+++ b/docs/files/final-presentation.pptx
@@ -200,9 +200,9 @@
             </a:lvl1pPr>
           </a:lstStyle>
           <a:p>
-            <a:fld id="{298102D2-35E2-4673-9299-B942999E275C}" type="datetimeFigureOut">
+            <a:fld id="{0087578C-8A03-4FFC-A6F0-0029C22226C9}" type="datetimeFigureOut">
               <a:rPr lang="zh-CN" altLang="en-US" smtClean="0"/>
-              <a:t>2026/10/25</a:t>
+              <a:t>2026/10/26</a:t>
             </a:fld>
             <a:endParaRPr lang="zh-CN" altLang="en-US"/>
           </a:p>
@@ -358,7 +358,7 @@
             </a:lvl1pPr>
           </a:lstStyle>
           <a:p>
-            <a:fld id="{95F083AB-F185-431B-9B8E-1CD32311317A}" type="slidenum">
+            <a:fld id="{DC3FFBA5-1DE7-484C-BC8E-2B230455CA7A}" type="slidenum">
               <a:rPr lang="zh-CN" altLang="en-US" smtClean="0"/>
               <a:t>‹#›</a:t>
             </a:fld>
@@ -369,7 +369,7 @@
     </p:spTree>
     <p:extLst>
       <p:ext uri="{BB962C8B-B14F-4D97-AF65-F5344CB8AC3E}">
-        <p14:creationId xmlns:p14="http://schemas.microsoft.com/office/powerpoint/2010/main" val="658115790"/>
+        <p14:creationId xmlns:p14="http://schemas.microsoft.com/office/powerpoint/2010/main" val="4241949968"/>
       </p:ext>
     </p:extLst>
   </p:cSld>
@@ -564,7 +564,7 @@
           <a:bodyPr/>
           <a:lstStyle/>
           <a:p>
-            <a:fld id="{95F083AB-F185-431B-9B8E-1CD32311317A}" type="slidenum">
+            <a:fld id="{DC3FFBA5-1DE7-484C-BC8E-2B230455CA7A}" type="slidenum">
               <a:rPr lang="zh-CN" altLang="en-US" smtClean="0"/>
               <a:t>1</a:t>
             </a:fld>
@@ -575,7 +575,7 @@
     </p:spTree>
     <p:extLst>
       <p:ext uri="{BB962C8B-B14F-4D97-AF65-F5344CB8AC3E}">
-        <p14:creationId xmlns:p14="http://schemas.microsoft.com/office/powerpoint/2010/main" val="3972946030"/>
+        <p14:creationId xmlns:p14="http://schemas.microsoft.com/office/powerpoint/2010/main" val="233737630"/>
       </p:ext>
     </p:extLst>
   </p:cSld>
@@ -766,7 +766,7 @@
           <a:bodyPr/>
           <a:lstStyle/>
           <a:p>
-            <a:fld id="{95F083AB-F185-431B-9B8E-1CD32311317A}" type="slidenum">
+            <a:fld id="{DC3FFBA5-1DE7-484C-BC8E-2B230455CA7A}" type="slidenum">
               <a:rPr lang="zh-CN" altLang="en-US" smtClean="0"/>
               <a:t>10</a:t>
             </a:fld>
@@ -777,7 +777,7 @@
     </p:spTree>
     <p:extLst>
       <p:ext uri="{BB962C8B-B14F-4D97-AF65-F5344CB8AC3E}">
-        <p14:creationId xmlns:p14="http://schemas.microsoft.com/office/powerpoint/2010/main" val="599418100"/>
+        <p14:creationId xmlns:p14="http://schemas.microsoft.com/office/powerpoint/2010/main" val="934599706"/>
       </p:ext>
     </p:extLst>
   </p:cSld>
@@ -936,7 +936,7 @@
           <a:bodyPr/>
           <a:lstStyle/>
           <a:p>
-            <a:fld id="{95F083AB-F185-431B-9B8E-1CD32311317A}" type="slidenum">
+            <a:fld id="{DC3FFBA5-1DE7-484C-BC8E-2B230455CA7A}" type="slidenum">
               <a:rPr lang="zh-CN" altLang="en-US" smtClean="0"/>
               <a:t>11</a:t>
             </a:fld>
@@ -947,7 +947,7 @@
     </p:spTree>
     <p:extLst>
       <p:ext uri="{BB962C8B-B14F-4D97-AF65-F5344CB8AC3E}">
-        <p14:creationId xmlns:p14="http://schemas.microsoft.com/office/powerpoint/2010/main" val="3727106175"/>
+        <p14:creationId xmlns:p14="http://schemas.microsoft.com/office/powerpoint/2010/main" val="1501486594"/>
       </p:ext>
     </p:extLst>
   </p:cSld>
@@ -1188,7 +1188,7 @@
           <a:bodyPr/>
           <a:lstStyle/>
           <a:p>
-            <a:fld id="{95F083AB-F185-431B-9B8E-1CD32311317A}" type="slidenum">
+            <a:fld id="{DC3FFBA5-1DE7-484C-BC8E-2B230455CA7A}" type="slidenum">
               <a:rPr lang="zh-CN" altLang="en-US" smtClean="0"/>
               <a:t>2</a:t>
             </a:fld>
@@ -1199,7 +1199,7 @@
     </p:spTree>
     <p:extLst>
       <p:ext uri="{BB962C8B-B14F-4D97-AF65-F5344CB8AC3E}">
-        <p14:creationId xmlns:p14="http://schemas.microsoft.com/office/powerpoint/2010/main" val="92011103"/>
+        <p14:creationId xmlns:p14="http://schemas.microsoft.com/office/powerpoint/2010/main" val="3859259947"/>
       </p:ext>
     </p:extLst>
   </p:cSld>
@@ -1528,7 +1528,7 @@
           <a:bodyPr/>
           <a:lstStyle/>
           <a:p>
-            <a:fld id="{95F083AB-F185-431B-9B8E-1CD32311317A}" type="slidenum">
+            <a:fld id="{DC3FFBA5-1DE7-484C-BC8E-2B230455CA7A}" type="slidenum">
               <a:rPr lang="zh-CN" altLang="en-US" smtClean="0"/>
               <a:t>3</a:t>
             </a:fld>
@@ -1539,7 +1539,7 @@
     </p:spTree>
     <p:extLst>
       <p:ext uri="{BB962C8B-B14F-4D97-AF65-F5344CB8AC3E}">
-        <p14:creationId xmlns:p14="http://schemas.microsoft.com/office/powerpoint/2010/main" val="3238772456"/>
+        <p14:creationId xmlns:p14="http://schemas.microsoft.com/office/powerpoint/2010/main" val="1012498084"/>
       </p:ext>
     </p:extLst>
   </p:cSld>
@@ -1780,7 +1780,7 @@
           <a:bodyPr/>
           <a:lstStyle/>
           <a:p>
-            <a:fld id="{95F083AB-F185-431B-9B8E-1CD32311317A}" type="slidenum">
+            <a:fld id="{DC3FFBA5-1DE7-484C-BC8E-2B230455CA7A}" type="slidenum">
               <a:rPr lang="zh-CN" altLang="en-US" smtClean="0"/>
               <a:t>4</a:t>
             </a:fld>
@@ -1791,7 +1791,7 @@
     </p:spTree>
     <p:extLst>
       <p:ext uri="{BB962C8B-B14F-4D97-AF65-F5344CB8AC3E}">
-        <p14:creationId xmlns:p14="http://schemas.microsoft.com/office/powerpoint/2010/main" val="1574271305"/>
+        <p14:creationId xmlns:p14="http://schemas.microsoft.com/office/powerpoint/2010/main" val="3859652036"/>
       </p:ext>
     </p:extLst>
   </p:cSld>
@@ -2056,7 +2056,7 @@
           <a:bodyPr/>
           <a:lstStyle/>
           <a:p>
-            <a:fld id="{95F083AB-F185-431B-9B8E-1CD32311317A}" type="slidenum">
+            <a:fld id="{DC3FFBA5-1DE7-484C-BC8E-2B230455CA7A}" type="slidenum">
               <a:rPr lang="zh-CN" altLang="en-US" smtClean="0"/>
               <a:t>5</a:t>
             </a:fld>
@@ -2067,7 +2067,7 @@
     </p:spTree>
     <p:extLst>
       <p:ext uri="{BB962C8B-B14F-4D97-AF65-F5344CB8AC3E}">
-        <p14:creationId xmlns:p14="http://schemas.microsoft.com/office/powerpoint/2010/main" val="1439700522"/>
+        <p14:creationId xmlns:p14="http://schemas.microsoft.com/office/powerpoint/2010/main" val="1556869467"/>
       </p:ext>
     </p:extLst>
   </p:cSld>
@@ -2340,7 +2340,7 @@
           <a:bodyPr/>
           <a:lstStyle/>
           <a:p>
-            <a:fld id="{95F083AB-F185-431B-9B8E-1CD32311317A}" type="slidenum">
+            <a:fld id="{DC3FFBA5-1DE7-484C-BC8E-2B230455CA7A}" type="slidenum">
               <a:rPr lang="zh-CN" altLang="en-US" smtClean="0"/>
               <a:t>6</a:t>
             </a:fld>
@@ -2351,7 +2351,7 @@
     </p:spTree>
     <p:extLst>
       <p:ext uri="{BB962C8B-B14F-4D97-AF65-F5344CB8AC3E}">
-        <p14:creationId xmlns:p14="http://schemas.microsoft.com/office/powerpoint/2010/main" val="3747372172"/>
+        <p14:creationId xmlns:p14="http://schemas.microsoft.com/office/powerpoint/2010/main" val="2464462379"/>
       </p:ext>
     </p:extLst>
   </p:cSld>
@@ -2656,7 +2656,7 @@
           <a:bodyPr/>
           <a:lstStyle/>
           <a:p>
-            <a:fld id="{95F083AB-F185-431B-9B8E-1CD32311317A}" type="slidenum">
+            <a:fld id="{DC3FFBA5-1DE7-484C-BC8E-2B230455CA7A}" type="slidenum">
               <a:rPr lang="zh-CN" altLang="en-US" smtClean="0"/>
               <a:t>7</a:t>
             </a:fld>
@@ -2667,7 +2667,7 @@
     </p:spTree>
     <p:extLst>
       <p:ext uri="{BB962C8B-B14F-4D97-AF65-F5344CB8AC3E}">
-        <p14:creationId xmlns:p14="http://schemas.microsoft.com/office/powerpoint/2010/main" val="1658007526"/>
+        <p14:creationId xmlns:p14="http://schemas.microsoft.com/office/powerpoint/2010/main" val="246500297"/>
       </p:ext>
     </p:extLst>
   </p:cSld>
@@ -2780,7 +2780,7 @@
           <a:bodyPr/>
           <a:lstStyle/>
           <a:p>
-            <a:fld id="{95F083AB-F185-431B-9B8E-1CD32311317A}" type="slidenum">
+            <a:fld id="{DC3FFBA5-1DE7-484C-BC8E-2B230455CA7A}" type="slidenum">
               <a:rPr lang="zh-CN" altLang="en-US" smtClean="0"/>
               <a:t>8</a:t>
             </a:fld>
@@ -2791,7 +2791,7 @@
     </p:spTree>
     <p:extLst>
       <p:ext uri="{BB962C8B-B14F-4D97-AF65-F5344CB8AC3E}">
-        <p14:creationId xmlns:p14="http://schemas.microsoft.com/office/powerpoint/2010/main" val="3300595126"/>
+        <p14:creationId xmlns:p14="http://schemas.microsoft.com/office/powerpoint/2010/main" val="4078746916"/>
       </p:ext>
     </p:extLst>
   </p:cSld>
@@ -3038,7 +3038,7 @@
           <a:bodyPr/>
           <a:lstStyle/>
           <a:p>
-            <a:fld id="{95F083AB-F185-431B-9B8E-1CD32311317A}" type="slidenum">
+            <a:fld id="{DC3FFBA5-1DE7-484C-BC8E-2B230455CA7A}" type="slidenum">
               <a:rPr lang="zh-CN" altLang="en-US" smtClean="0"/>
               <a:t>9</a:t>
             </a:fld>
@@ -3049,7 +3049,7 @@
     </p:spTree>
     <p:extLst>
       <p:ext uri="{BB962C8B-B14F-4D97-AF65-F5344CB8AC3E}">
-        <p14:creationId xmlns:p14="http://schemas.microsoft.com/office/powerpoint/2010/main" val="69199922"/>
+        <p14:creationId xmlns:p14="http://schemas.microsoft.com/office/powerpoint/2010/main" val="1595323193"/>
       </p:ext>
     </p:extLst>
   </p:cSld>
@@ -3081,7 +3081,7 @@
           <p:cNvPr id="2" name="标题 1">
             <a:extLst>
               <a:ext uri="{FF2B5EF4-FFF2-40B4-BE49-F238E27FC236}">
-                <a16:creationId xmlns:a16="http://schemas.microsoft.com/office/drawing/2014/main" id="{37CEF1F7-FAC1-72B3-5AA1-7DCBD994390C}"/>
+                <a16:creationId xmlns:a16="http://schemas.microsoft.com/office/drawing/2014/main" id="{A3F0E5E0-B355-94BB-F093-6D316755A615}"/>
               </a:ext>
             </a:extLst>
           </p:cNvPr>
@@ -3118,7 +3118,7 @@
           <p:cNvPr id="3" name="副标题 2">
             <a:extLst>
               <a:ext uri="{FF2B5EF4-FFF2-40B4-BE49-F238E27FC236}">
-                <a16:creationId xmlns:a16="http://schemas.microsoft.com/office/drawing/2014/main" id="{A984778D-05F7-4E50-EAC7-66D568AD239C}"/>
+                <a16:creationId xmlns:a16="http://schemas.microsoft.com/office/drawing/2014/main" id="{43D6E206-CFDA-AD47-8473-6495F6D5A086}"/>
               </a:ext>
             </a:extLst>
           </p:cNvPr>
@@ -3188,7 +3188,7 @@
           <p:cNvPr id="4" name="日期占位符 3">
             <a:extLst>
               <a:ext uri="{FF2B5EF4-FFF2-40B4-BE49-F238E27FC236}">
-                <a16:creationId xmlns:a16="http://schemas.microsoft.com/office/drawing/2014/main" id="{CA3E72D3-34FC-AA41-A986-3CB38547A54A}"/>
+                <a16:creationId xmlns:a16="http://schemas.microsoft.com/office/drawing/2014/main" id="{4FE9A6F1-B259-9B9B-58EC-9EA6BFA36809}"/>
               </a:ext>
             </a:extLst>
           </p:cNvPr>
@@ -3204,9 +3204,9 @@
           <a:bodyPr/>
           <a:lstStyle/>
           <a:p>
-            <a:fld id="{B58E3282-6649-466A-831A-89CC55B996F1}" type="datetimeFigureOut">
+            <a:fld id="{D0201DBD-0E3D-42B7-B956-71A8E5FDA919}" type="datetimeFigureOut">
               <a:rPr lang="zh-CN" altLang="en-US" smtClean="0"/>
-              <a:t>2026/10/25</a:t>
+              <a:t>2026/10/26</a:t>
             </a:fld>
             <a:endParaRPr lang="zh-CN" altLang="en-US"/>
           </a:p>
@@ -3217,7 +3217,7 @@
           <p:cNvPr id="5" name="页脚占位符 4">
             <a:extLst>
               <a:ext uri="{FF2B5EF4-FFF2-40B4-BE49-F238E27FC236}">
-                <a16:creationId xmlns:a16="http://schemas.microsoft.com/office/drawing/2014/main" id="{C20892F1-3126-9BD2-35D2-A4279C9C568A}"/>
+                <a16:creationId xmlns:a16="http://schemas.microsoft.com/office/drawing/2014/main" id="{2A9D0F36-70A2-A99E-27E5-831783FF67E2}"/>
               </a:ext>
             </a:extLst>
           </p:cNvPr>
@@ -3242,7 +3242,7 @@
           <p:cNvPr id="6" name="灯片编号占位符 5">
             <a:extLst>
               <a:ext uri="{FF2B5EF4-FFF2-40B4-BE49-F238E27FC236}">
-                <a16:creationId xmlns:a16="http://schemas.microsoft.com/office/drawing/2014/main" id="{915B8BED-C2B3-021E-E29B-95B0F2C5A103}"/>
+                <a16:creationId xmlns:a16="http://schemas.microsoft.com/office/drawing/2014/main" id="{6A0BDE99-E889-9ED2-B630-EAD504EADCCB}"/>
               </a:ext>
             </a:extLst>
           </p:cNvPr>
@@ -3258,7 +3258,7 @@
           <a:bodyPr/>
           <a:lstStyle/>
           <a:p>
-            <a:fld id="{CAA8DFD1-E9DF-4CED-B539-E78C2BF12841}" type="slidenum">
+            <a:fld id="{FD1A6613-956C-45BA-BE1E-3C432AF7978A}" type="slidenum">
               <a:rPr lang="zh-CN" altLang="en-US" smtClean="0"/>
               <a:t>‹#›</a:t>
             </a:fld>
@@ -3269,7 +3269,7 @@
     </p:spTree>
     <p:extLst>
       <p:ext uri="{BB962C8B-B14F-4D97-AF65-F5344CB8AC3E}">
-        <p14:creationId xmlns:p14="http://schemas.microsoft.com/office/powerpoint/2010/main" val="3706540"/>
+        <p14:creationId xmlns:p14="http://schemas.microsoft.com/office/powerpoint/2010/main" val="4286197163"/>
       </p:ext>
     </p:extLst>
   </p:cSld>
@@ -3301,7 +3301,7 @@
           <p:cNvPr id="2" name="标题 1">
             <a:extLst>
               <a:ext uri="{FF2B5EF4-FFF2-40B4-BE49-F238E27FC236}">
-                <a16:creationId xmlns:a16="http://schemas.microsoft.com/office/drawing/2014/main" id="{7D4C2027-7D8B-7FD9-9391-5B22EF111D40}"/>
+                <a16:creationId xmlns:a16="http://schemas.microsoft.com/office/drawing/2014/main" id="{1F1CDC8D-95BE-0DDE-CD57-118B8AFE7841}"/>
               </a:ext>
             </a:extLst>
           </p:cNvPr>
@@ -3329,7 +3329,7 @@
           <p:cNvPr id="3" name="竖排文字占位符 2">
             <a:extLst>
               <a:ext uri="{FF2B5EF4-FFF2-40B4-BE49-F238E27FC236}">
-                <a16:creationId xmlns:a16="http://schemas.microsoft.com/office/drawing/2014/main" id="{E95CE49C-1BA5-8DF2-B1DA-AB25166598A5}"/>
+                <a16:creationId xmlns:a16="http://schemas.microsoft.com/office/drawing/2014/main" id="{D9C81D36-9503-BF0E-E43D-4418142C9BA3}"/>
               </a:ext>
             </a:extLst>
           </p:cNvPr>
@@ -3386,7 +3386,7 @@
           <p:cNvPr id="4" name="日期占位符 3">
             <a:extLst>
               <a:ext uri="{FF2B5EF4-FFF2-40B4-BE49-F238E27FC236}">
-                <a16:creationId xmlns:a16="http://schemas.microsoft.com/office/drawing/2014/main" id="{F0CF572E-C9D2-A16E-9F18-02F1A029C385}"/>
+                <a16:creationId xmlns:a16="http://schemas.microsoft.com/office/drawing/2014/main" id="{44557099-BCB9-1075-C20D-76E2021D06B3}"/>
               </a:ext>
             </a:extLst>
           </p:cNvPr>
@@ -3402,9 +3402,9 @@
           <a:bodyPr/>
           <a:lstStyle/>
           <a:p>
-            <a:fld id="{B58E3282-6649-466A-831A-89CC55B996F1}" type="datetimeFigureOut">
+            <a:fld id="{D0201DBD-0E3D-42B7-B956-71A8E5FDA919}" type="datetimeFigureOut">
               <a:rPr lang="zh-CN" altLang="en-US" smtClean="0"/>
-              <a:t>2026/10/25</a:t>
+              <a:t>2026/10/26</a:t>
             </a:fld>
             <a:endParaRPr lang="zh-CN" altLang="en-US"/>
           </a:p>
@@ -3415,7 +3415,7 @@
           <p:cNvPr id="5" name="页脚占位符 4">
             <a:extLst>
               <a:ext uri="{FF2B5EF4-FFF2-40B4-BE49-F238E27FC236}">
-                <a16:creationId xmlns:a16="http://schemas.microsoft.com/office/drawing/2014/main" id="{2B55CB60-CD77-CAE7-2D76-8A5DFEABEC98}"/>
+                <a16:creationId xmlns:a16="http://schemas.microsoft.com/office/drawing/2014/main" id="{36E6C89F-7995-7708-10A8-E34BD59F650B}"/>
               </a:ext>
             </a:extLst>
           </p:cNvPr>
@@ -3440,7 +3440,7 @@
           <p:cNvPr id="6" name="灯片编号占位符 5">
             <a:extLst>
               <a:ext uri="{FF2B5EF4-FFF2-40B4-BE49-F238E27FC236}">
-                <a16:creationId xmlns:a16="http://schemas.microsoft.com/office/drawing/2014/main" id="{697408F9-99B2-3BEA-FDDF-3D29B5FC8E36}"/>
+                <a16:creationId xmlns:a16="http://schemas.microsoft.com/office/drawing/2014/main" id="{33087AFB-1123-9DDD-2AAE-D23AD3C913DE}"/>
               </a:ext>
             </a:extLst>
           </p:cNvPr>
@@ -3456,7 +3456,7 @@
           <a:bodyPr/>
           <a:lstStyle/>
           <a:p>
-            <a:fld id="{CAA8DFD1-E9DF-4CED-B539-E78C2BF12841}" type="slidenum">
+            <a:fld id="{FD1A6613-956C-45BA-BE1E-3C432AF7978A}" type="slidenum">
               <a:rPr lang="zh-CN" altLang="en-US" smtClean="0"/>
               <a:t>‹#›</a:t>
             </a:fld>
@@ -3467,7 +3467,7 @@
     </p:spTree>
     <p:extLst>
       <p:ext uri="{BB962C8B-B14F-4D97-AF65-F5344CB8AC3E}">
-        <p14:creationId xmlns:p14="http://schemas.microsoft.com/office/powerpoint/2010/main" val="561562957"/>
+        <p14:creationId xmlns:p14="http://schemas.microsoft.com/office/powerpoint/2010/main" val="2688841552"/>
       </p:ext>
     </p:extLst>
   </p:cSld>
@@ -3499,7 +3499,7 @@
           <p:cNvPr id="2" name="竖排标题 1">
             <a:extLst>
               <a:ext uri="{FF2B5EF4-FFF2-40B4-BE49-F238E27FC236}">
-                <a16:creationId xmlns:a16="http://schemas.microsoft.com/office/drawing/2014/main" id="{4A8488E4-FF05-222B-E1C7-7F857B861DE5}"/>
+                <a16:creationId xmlns:a16="http://schemas.microsoft.com/office/drawing/2014/main" id="{A342E6CD-AA65-C1C3-4231-64D8BE03DFEC}"/>
               </a:ext>
             </a:extLst>
           </p:cNvPr>
@@ -3532,7 +3532,7 @@
           <p:cNvPr id="3" name="竖排文字占位符 2">
             <a:extLst>
               <a:ext uri="{FF2B5EF4-FFF2-40B4-BE49-F238E27FC236}">
-                <a16:creationId xmlns:a16="http://schemas.microsoft.com/office/drawing/2014/main" id="{D36C2CC1-F91F-2E54-4925-2CC5E22F7AC3}"/>
+                <a16:creationId xmlns:a16="http://schemas.microsoft.com/office/drawing/2014/main" id="{369A1F87-0DDF-D916-EBE3-7EBE049F7791}"/>
               </a:ext>
             </a:extLst>
           </p:cNvPr>
@@ -3594,7 +3594,7 @@
           <p:cNvPr id="4" name="日期占位符 3">
             <a:extLst>
               <a:ext uri="{FF2B5EF4-FFF2-40B4-BE49-F238E27FC236}">
-                <a16:creationId xmlns:a16="http://schemas.microsoft.com/office/drawing/2014/main" id="{0DD85DE7-E2C5-8A8B-DFF9-BCF1AF5C2155}"/>
+                <a16:creationId xmlns:a16="http://schemas.microsoft.com/office/drawing/2014/main" id="{4E230FA9-8BF3-C1B5-F004-D2684E0EB4D7}"/>
               </a:ext>
             </a:extLst>
           </p:cNvPr>
@@ -3610,9 +3610,9 @@
           <a:bodyPr/>
           <a:lstStyle/>
           <a:p>
-            <a:fld id="{B58E3282-6649-466A-831A-89CC55B996F1}" type="datetimeFigureOut">
+            <a:fld id="{D0201DBD-0E3D-42B7-B956-71A8E5FDA919}" type="datetimeFigureOut">
               <a:rPr lang="zh-CN" altLang="en-US" smtClean="0"/>
-              <a:t>2026/10/25</a:t>
+              <a:t>2026/10/26</a:t>
             </a:fld>
             <a:endParaRPr lang="zh-CN" altLang="en-US"/>
           </a:p>
@@ -3623,7 +3623,7 @@
           <p:cNvPr id="5" name="页脚占位符 4">
             <a:extLst>
               <a:ext uri="{FF2B5EF4-FFF2-40B4-BE49-F238E27FC236}">
-                <a16:creationId xmlns:a16="http://schemas.microsoft.com/office/drawing/2014/main" id="{966BBDDD-5890-791A-687C-90AE01CBD0F5}"/>
+                <a16:creationId xmlns:a16="http://schemas.microsoft.com/office/drawing/2014/main" id="{BEB7DFFF-0AB3-EC23-E08F-1A8C8F4FCF3A}"/>
               </a:ext>
             </a:extLst>
           </p:cNvPr>
@@ -3648,7 +3648,7 @@
           <p:cNvPr id="6" name="灯片编号占位符 5">
             <a:extLst>
               <a:ext uri="{FF2B5EF4-FFF2-40B4-BE49-F238E27FC236}">
-                <a16:creationId xmlns:a16="http://schemas.microsoft.com/office/drawing/2014/main" id="{0C9A8D07-7927-02BA-D8A1-06D808FF67C5}"/>
+                <a16:creationId xmlns:a16="http://schemas.microsoft.com/office/drawing/2014/main" id="{BE1E0044-9DED-491E-5D4F-77C60791A1F0}"/>
               </a:ext>
             </a:extLst>
           </p:cNvPr>
@@ -3664,7 +3664,7 @@
           <a:bodyPr/>
           <a:lstStyle/>
           <a:p>
-            <a:fld id="{CAA8DFD1-E9DF-4CED-B539-E78C2BF12841}" type="slidenum">
+            <a:fld id="{FD1A6613-956C-45BA-BE1E-3C432AF7978A}" type="slidenum">
               <a:rPr lang="zh-CN" altLang="en-US" smtClean="0"/>
               <a:t>‹#›</a:t>
             </a:fld>
@@ -3675,7 +3675,7 @@
     </p:spTree>
     <p:extLst>
       <p:ext uri="{BB962C8B-B14F-4D97-AF65-F5344CB8AC3E}">
-        <p14:creationId xmlns:p14="http://schemas.microsoft.com/office/powerpoint/2010/main" val="482976511"/>
+        <p14:creationId xmlns:p14="http://schemas.microsoft.com/office/powerpoint/2010/main" val="3481940196"/>
       </p:ext>
     </p:extLst>
   </p:cSld>
@@ -3707,7 +3707,7 @@
           <p:cNvPr id="2" name="标题 1">
             <a:extLst>
               <a:ext uri="{FF2B5EF4-FFF2-40B4-BE49-F238E27FC236}">
-                <a16:creationId xmlns:a16="http://schemas.microsoft.com/office/drawing/2014/main" id="{4E9A37CD-33A4-0869-02AC-4375F89D7CA3}"/>
+                <a16:creationId xmlns:a16="http://schemas.microsoft.com/office/drawing/2014/main" id="{B4CEFEFE-7378-500D-358E-79EB2D668136}"/>
               </a:ext>
             </a:extLst>
           </p:cNvPr>
@@ -3735,7 +3735,7 @@
           <p:cNvPr id="3" name="内容占位符 2">
             <a:extLst>
               <a:ext uri="{FF2B5EF4-FFF2-40B4-BE49-F238E27FC236}">
-                <a16:creationId xmlns:a16="http://schemas.microsoft.com/office/drawing/2014/main" id="{5D26E3DB-F91C-6580-CAC0-C59BE9CD602C}"/>
+                <a16:creationId xmlns:a16="http://schemas.microsoft.com/office/drawing/2014/main" id="{79165AB0-4F4D-64E4-81F9-100EF2803652}"/>
               </a:ext>
             </a:extLst>
           </p:cNvPr>
@@ -3792,7 +3792,7 @@
           <p:cNvPr id="4" name="日期占位符 3">
             <a:extLst>
               <a:ext uri="{FF2B5EF4-FFF2-40B4-BE49-F238E27FC236}">
-                <a16:creationId xmlns:a16="http://schemas.microsoft.com/office/drawing/2014/main" id="{25F56ED6-AE01-556E-174B-C08880C68C79}"/>
+                <a16:creationId xmlns:a16="http://schemas.microsoft.com/office/drawing/2014/main" id="{38B77EFF-BDB5-7057-8C9A-A59253610E71}"/>
               </a:ext>
             </a:extLst>
           </p:cNvPr>
@@ -3808,9 +3808,9 @@
           <a:bodyPr/>
           <a:lstStyle/>
           <a:p>
-            <a:fld id="{B58E3282-6649-466A-831A-89CC55B996F1}" type="datetimeFigureOut">
+            <a:fld id="{D0201DBD-0E3D-42B7-B956-71A8E5FDA919}" type="datetimeFigureOut">
               <a:rPr lang="zh-CN" altLang="en-US" smtClean="0"/>
-              <a:t>2026/10/25</a:t>
+              <a:t>2026/10/26</a:t>
             </a:fld>
             <a:endParaRPr lang="zh-CN" altLang="en-US"/>
           </a:p>
@@ -3821,7 +3821,7 @@
           <p:cNvPr id="5" name="页脚占位符 4">
             <a:extLst>
               <a:ext uri="{FF2B5EF4-FFF2-40B4-BE49-F238E27FC236}">
-                <a16:creationId xmlns:a16="http://schemas.microsoft.com/office/drawing/2014/main" id="{79A80264-DA96-8DC9-8FAF-402C932400BF}"/>
+                <a16:creationId xmlns:a16="http://schemas.microsoft.com/office/drawing/2014/main" id="{8C6D90CF-F743-6751-8B70-4A9CBEBDF785}"/>
               </a:ext>
             </a:extLst>
           </p:cNvPr>
@@ -3846,7 +3846,7 @@
           <p:cNvPr id="6" name="灯片编号占位符 5">
             <a:extLst>
               <a:ext uri="{FF2B5EF4-FFF2-40B4-BE49-F238E27FC236}">
-                <a16:creationId xmlns:a16="http://schemas.microsoft.com/office/drawing/2014/main" id="{E1DDD14F-49AC-3C5F-DFF0-A9F75AD6069C}"/>
+                <a16:creationId xmlns:a16="http://schemas.microsoft.com/office/drawing/2014/main" id="{2A634A2F-B5A6-4EFD-8BEF-AE9CF108BCFD}"/>
               </a:ext>
             </a:extLst>
           </p:cNvPr>
@@ -3862,7 +3862,7 @@
           <a:bodyPr/>
           <a:lstStyle/>
           <a:p>
-            <a:fld id="{CAA8DFD1-E9DF-4CED-B539-E78C2BF12841}" type="slidenum">
+            <a:fld id="{FD1A6613-956C-45BA-BE1E-3C432AF7978A}" type="slidenum">
               <a:rPr lang="zh-CN" altLang="en-US" smtClean="0"/>
               <a:t>‹#›</a:t>
             </a:fld>
@@ -3873,7 +3873,7 @@
     </p:spTree>
     <p:extLst>
       <p:ext uri="{BB962C8B-B14F-4D97-AF65-F5344CB8AC3E}">
-        <p14:creationId xmlns:p14="http://schemas.microsoft.com/office/powerpoint/2010/main" val="3835378348"/>
+        <p14:creationId xmlns:p14="http://schemas.microsoft.com/office/powerpoint/2010/main" val="1667523885"/>
       </p:ext>
     </p:extLst>
   </p:cSld>
@@ -3905,7 +3905,7 @@
           <p:cNvPr id="2" name="标题 1">
             <a:extLst>
               <a:ext uri="{FF2B5EF4-FFF2-40B4-BE49-F238E27FC236}">
-                <a16:creationId xmlns:a16="http://schemas.microsoft.com/office/drawing/2014/main" id="{E12ABEDE-930A-C2E0-DFC7-C8CC33F63099}"/>
+                <a16:creationId xmlns:a16="http://schemas.microsoft.com/office/drawing/2014/main" id="{44881D92-E005-0970-EE9C-5060750B0E29}"/>
               </a:ext>
             </a:extLst>
           </p:cNvPr>
@@ -3942,7 +3942,7 @@
           <p:cNvPr id="3" name="文本占位符 2">
             <a:extLst>
               <a:ext uri="{FF2B5EF4-FFF2-40B4-BE49-F238E27FC236}">
-                <a16:creationId xmlns:a16="http://schemas.microsoft.com/office/drawing/2014/main" id="{28AAAE2A-8948-FDDB-A061-98322FCF0B17}"/>
+                <a16:creationId xmlns:a16="http://schemas.microsoft.com/office/drawing/2014/main" id="{281250AB-E788-3DB6-A423-52E8F5397125}"/>
               </a:ext>
             </a:extLst>
           </p:cNvPr>
@@ -4067,7 +4067,7 @@
           <p:cNvPr id="4" name="日期占位符 3">
             <a:extLst>
               <a:ext uri="{FF2B5EF4-FFF2-40B4-BE49-F238E27FC236}">
-                <a16:creationId xmlns:a16="http://schemas.microsoft.com/office/drawing/2014/main" id="{B5FF6A3F-35A7-A4D3-0E21-F95868CBDA95}"/>
+                <a16:creationId xmlns:a16="http://schemas.microsoft.com/office/drawing/2014/main" id="{3A8A85AB-5EBF-9FDB-D27C-894B2840515E}"/>
               </a:ext>
             </a:extLst>
           </p:cNvPr>
@@ -4083,9 +4083,9 @@
           <a:bodyPr/>
           <a:lstStyle/>
           <a:p>
-            <a:fld id="{B58E3282-6649-466A-831A-89CC55B996F1}" type="datetimeFigureOut">
+            <a:fld id="{D0201DBD-0E3D-42B7-B956-71A8E5FDA919}" type="datetimeFigureOut">
               <a:rPr lang="zh-CN" altLang="en-US" smtClean="0"/>
-              <a:t>2026/10/25</a:t>
+              <a:t>2026/10/26</a:t>
             </a:fld>
             <a:endParaRPr lang="zh-CN" altLang="en-US"/>
           </a:p>
@@ -4096,7 +4096,7 @@
           <p:cNvPr id="5" name="页脚占位符 4">
             <a:extLst>
               <a:ext uri="{FF2B5EF4-FFF2-40B4-BE49-F238E27FC236}">
-                <a16:creationId xmlns:a16="http://schemas.microsoft.com/office/drawing/2014/main" id="{4AF8C4FB-33CE-3141-5047-A96B61EB0B81}"/>
+                <a16:creationId xmlns:a16="http://schemas.microsoft.com/office/drawing/2014/main" id="{4E0E48B3-B573-5B21-B12E-F80DFF637DF4}"/>
               </a:ext>
             </a:extLst>
           </p:cNvPr>
@@ -4121,7 +4121,7 @@
           <p:cNvPr id="6" name="灯片编号占位符 5">
             <a:extLst>
               <a:ext uri="{FF2B5EF4-FFF2-40B4-BE49-F238E27FC236}">
-                <a16:creationId xmlns:a16="http://schemas.microsoft.com/office/drawing/2014/main" id="{A557BF04-709D-3C5F-E7C0-7C22A796F2FD}"/>
+                <a16:creationId xmlns:a16="http://schemas.microsoft.com/office/drawing/2014/main" id="{BEC41118-B87E-9655-8EDD-221469B228D7}"/>
               </a:ext>
             </a:extLst>
           </p:cNvPr>
@@ -4137,7 +4137,7 @@
           <a:bodyPr/>
           <a:lstStyle/>
           <a:p>
-            <a:fld id="{CAA8DFD1-E9DF-4CED-B539-E78C2BF12841}" type="slidenum">
+            <a:fld id="{FD1A6613-956C-45BA-BE1E-3C432AF7978A}" type="slidenum">
               <a:rPr lang="zh-CN" altLang="en-US" smtClean="0"/>
               <a:t>‹#›</a:t>
             </a:fld>
@@ -4148,7 +4148,7 @@
     </p:spTree>
     <p:extLst>
       <p:ext uri="{BB962C8B-B14F-4D97-AF65-F5344CB8AC3E}">
-        <p14:creationId xmlns:p14="http://schemas.microsoft.com/office/powerpoint/2010/main" val="729073336"/>
+        <p14:creationId xmlns:p14="http://schemas.microsoft.com/office/powerpoint/2010/main" val="348036988"/>
       </p:ext>
     </p:extLst>
   </p:cSld>
@@ -4180,7 +4180,7 @@
           <p:cNvPr id="2" name="标题 1">
             <a:extLst>
               <a:ext uri="{FF2B5EF4-FFF2-40B4-BE49-F238E27FC236}">
-                <a16:creationId xmlns:a16="http://schemas.microsoft.com/office/drawing/2014/main" id="{A024D5AA-81EE-1B7A-5C97-3F89CDF197F5}"/>
+                <a16:creationId xmlns:a16="http://schemas.microsoft.com/office/drawing/2014/main" id="{2FC7154E-92AC-E33E-C75C-68CB17E247B7}"/>
               </a:ext>
             </a:extLst>
           </p:cNvPr>
@@ -4208,7 +4208,7 @@
           <p:cNvPr id="3" name="内容占位符 2">
             <a:extLst>
               <a:ext uri="{FF2B5EF4-FFF2-40B4-BE49-F238E27FC236}">
-                <a16:creationId xmlns:a16="http://schemas.microsoft.com/office/drawing/2014/main" id="{2C3185AF-164C-A3F0-81F4-051B7F14A52C}"/>
+                <a16:creationId xmlns:a16="http://schemas.microsoft.com/office/drawing/2014/main" id="{E79DA795-6EBA-E852-A643-D89D487922FA}"/>
               </a:ext>
             </a:extLst>
           </p:cNvPr>
@@ -4270,7 +4270,7 @@
           <p:cNvPr id="4" name="内容占位符 3">
             <a:extLst>
               <a:ext uri="{FF2B5EF4-FFF2-40B4-BE49-F238E27FC236}">
-                <a16:creationId xmlns:a16="http://schemas.microsoft.com/office/drawing/2014/main" id="{95B5EF57-0B8A-BB38-CB21-A7727B300F61}"/>
+                <a16:creationId xmlns:a16="http://schemas.microsoft.com/office/drawing/2014/main" id="{9AC51D83-8081-6973-3B15-856CE4362945}"/>
               </a:ext>
             </a:extLst>
           </p:cNvPr>
@@ -4332,7 +4332,7 @@
           <p:cNvPr id="5" name="日期占位符 4">
             <a:extLst>
               <a:ext uri="{FF2B5EF4-FFF2-40B4-BE49-F238E27FC236}">
-                <a16:creationId xmlns:a16="http://schemas.microsoft.com/office/drawing/2014/main" id="{7D2BD0DB-B3E9-3A72-8BED-FA999900FA2E}"/>
+                <a16:creationId xmlns:a16="http://schemas.microsoft.com/office/drawing/2014/main" id="{1A72EACA-3D24-FA0D-BA4C-B69DA25DC277}"/>
               </a:ext>
             </a:extLst>
           </p:cNvPr>
@@ -4348,9 +4348,9 @@
           <a:bodyPr/>
           <a:lstStyle/>
           <a:p>
-            <a:fld id="{B58E3282-6649-466A-831A-89CC55B996F1}" type="datetimeFigureOut">
+            <a:fld id="{D0201DBD-0E3D-42B7-B956-71A8E5FDA919}" type="datetimeFigureOut">
               <a:rPr lang="zh-CN" altLang="en-US" smtClean="0"/>
-              <a:t>2026/10/25</a:t>
+              <a:t>2026/10/26</a:t>
             </a:fld>
             <a:endParaRPr lang="zh-CN" altLang="en-US"/>
           </a:p>
@@ -4361,7 +4361,7 @@
           <p:cNvPr id="6" name="页脚占位符 5">
             <a:extLst>
               <a:ext uri="{FF2B5EF4-FFF2-40B4-BE49-F238E27FC236}">
-                <a16:creationId xmlns:a16="http://schemas.microsoft.com/office/drawing/2014/main" id="{07BC1FE7-FAFC-7DF4-C820-7C9C67ABA709}"/>
+                <a16:creationId xmlns:a16="http://schemas.microsoft.com/office/drawing/2014/main" id="{A7A135F8-58C7-EDC1-890A-B366A7EE2B21}"/>
               </a:ext>
             </a:extLst>
           </p:cNvPr>
@@ -4386,7 +4386,7 @@
           <p:cNvPr id="7" name="灯片编号占位符 6">
             <a:extLst>
               <a:ext uri="{FF2B5EF4-FFF2-40B4-BE49-F238E27FC236}">
-                <a16:creationId xmlns:a16="http://schemas.microsoft.com/office/drawing/2014/main" id="{87D57C25-8602-6919-8094-91EB78ABD06C}"/>
+                <a16:creationId xmlns:a16="http://schemas.microsoft.com/office/drawing/2014/main" id="{77D5B1E5-4B14-DF47-B225-86F904A41AF2}"/>
               </a:ext>
             </a:extLst>
           </p:cNvPr>
@@ -4402,7 +4402,7 @@
           <a:bodyPr/>
           <a:lstStyle/>
           <a:p>
-            <a:fld id="{CAA8DFD1-E9DF-4CED-B539-E78C2BF12841}" type="slidenum">
+            <a:fld id="{FD1A6613-956C-45BA-BE1E-3C432AF7978A}" type="slidenum">
               <a:rPr lang="zh-CN" altLang="en-US" smtClean="0"/>
               <a:t>‹#›</a:t>
             </a:fld>
@@ -4413,7 +4413,7 @@
     </p:spTree>
     <p:extLst>
       <p:ext uri="{BB962C8B-B14F-4D97-AF65-F5344CB8AC3E}">
-        <p14:creationId xmlns:p14="http://schemas.microsoft.com/office/powerpoint/2010/main" val="1607266806"/>
+        <p14:creationId xmlns:p14="http://schemas.microsoft.com/office/powerpoint/2010/main" val="1759679046"/>
       </p:ext>
     </p:extLst>
   </p:cSld>
@@ -4445,7 +4445,7 @@
           <p:cNvPr id="2" name="标题 1">
             <a:extLst>
               <a:ext uri="{FF2B5EF4-FFF2-40B4-BE49-F238E27FC236}">
-                <a16:creationId xmlns:a16="http://schemas.microsoft.com/office/drawing/2014/main" id="{3F42C233-C3FA-FDF0-BD1D-DFE35C0627DB}"/>
+                <a16:creationId xmlns:a16="http://schemas.microsoft.com/office/drawing/2014/main" id="{CE1130CB-9438-659C-EC68-404C80169C16}"/>
               </a:ext>
             </a:extLst>
           </p:cNvPr>
@@ -4478,7 +4478,7 @@
           <p:cNvPr id="3" name="文本占位符 2">
             <a:extLst>
               <a:ext uri="{FF2B5EF4-FFF2-40B4-BE49-F238E27FC236}">
-                <a16:creationId xmlns:a16="http://schemas.microsoft.com/office/drawing/2014/main" id="{5F67391F-A163-CE34-7A81-C548889E069D}"/>
+                <a16:creationId xmlns:a16="http://schemas.microsoft.com/office/drawing/2014/main" id="{2DBE585A-0E0A-BC17-7FE1-0386A5F02B2F}"/>
               </a:ext>
             </a:extLst>
           </p:cNvPr>
@@ -4549,7 +4549,7 @@
           <p:cNvPr id="4" name="内容占位符 3">
             <a:extLst>
               <a:ext uri="{FF2B5EF4-FFF2-40B4-BE49-F238E27FC236}">
-                <a16:creationId xmlns:a16="http://schemas.microsoft.com/office/drawing/2014/main" id="{FD8C8C14-8F78-E159-667F-5CA3E9812899}"/>
+                <a16:creationId xmlns:a16="http://schemas.microsoft.com/office/drawing/2014/main" id="{433BC30E-B1D2-6A5F-CF09-6110E8D42990}"/>
               </a:ext>
             </a:extLst>
           </p:cNvPr>
@@ -4611,7 +4611,7 @@
           <p:cNvPr id="5" name="文本占位符 4">
             <a:extLst>
               <a:ext uri="{FF2B5EF4-FFF2-40B4-BE49-F238E27FC236}">
-                <a16:creationId xmlns:a16="http://schemas.microsoft.com/office/drawing/2014/main" id="{D290985A-B000-2CA8-05A4-72FA97DFBADF}"/>
+                <a16:creationId xmlns:a16="http://schemas.microsoft.com/office/drawing/2014/main" id="{D48BAB7F-3482-70CA-554C-2435F958AEAA}"/>
               </a:ext>
             </a:extLst>
           </p:cNvPr>
@@ -4682,7 +4682,7 @@
           <p:cNvPr id="6" name="内容占位符 5">
             <a:extLst>
               <a:ext uri="{FF2B5EF4-FFF2-40B4-BE49-F238E27FC236}">
-                <a16:creationId xmlns:a16="http://schemas.microsoft.com/office/drawing/2014/main" id="{2F6362DC-BD65-4187-68C1-1859845CBF5E}"/>
+                <a16:creationId xmlns:a16="http://schemas.microsoft.com/office/drawing/2014/main" id="{23D8B33D-06AD-3F18-A45C-FCF85F1B6640}"/>
               </a:ext>
             </a:extLst>
           </p:cNvPr>
@@ -4744,7 +4744,7 @@
           <p:cNvPr id="7" name="日期占位符 6">
             <a:extLst>
               <a:ext uri="{FF2B5EF4-FFF2-40B4-BE49-F238E27FC236}">
-                <a16:creationId xmlns:a16="http://schemas.microsoft.com/office/drawing/2014/main" id="{3E10D4E6-E247-68F7-7C94-B96B80188D24}"/>
+                <a16:creationId xmlns:a16="http://schemas.microsoft.com/office/drawing/2014/main" id="{866CEA7D-B9CF-8CE0-EA0B-AE12781A2EF5}"/>
               </a:ext>
             </a:extLst>
           </p:cNvPr>
@@ -4760,9 +4760,9 @@
           <a:bodyPr/>
           <a:lstStyle/>
           <a:p>
-            <a:fld id="{B58E3282-6649-466A-831A-89CC55B996F1}" type="datetimeFigureOut">
+            <a:fld id="{D0201DBD-0E3D-42B7-B956-71A8E5FDA919}" type="datetimeFigureOut">
               <a:rPr lang="zh-CN" altLang="en-US" smtClean="0"/>
-              <a:t>2026/10/25</a:t>
+              <a:t>2026/10/26</a:t>
             </a:fld>
             <a:endParaRPr lang="zh-CN" altLang="en-US"/>
           </a:p>
@@ -4773,7 +4773,7 @@
           <p:cNvPr id="8" name="页脚占位符 7">
             <a:extLst>
               <a:ext uri="{FF2B5EF4-FFF2-40B4-BE49-F238E27FC236}">
-                <a16:creationId xmlns:a16="http://schemas.microsoft.com/office/drawing/2014/main" id="{D5AC78C4-2D6A-A312-0EF5-E38BE189C808}"/>
+                <a16:creationId xmlns:a16="http://schemas.microsoft.com/office/drawing/2014/main" id="{12815F6E-E2EA-C281-D190-E1EFC8580A39}"/>
               </a:ext>
             </a:extLst>
           </p:cNvPr>
@@ -4798,7 +4798,7 @@
           <p:cNvPr id="9" name="灯片编号占位符 8">
             <a:extLst>
               <a:ext uri="{FF2B5EF4-FFF2-40B4-BE49-F238E27FC236}">
-                <a16:creationId xmlns:a16="http://schemas.microsoft.com/office/drawing/2014/main" id="{A4BA5360-9E3A-FDB8-9770-9698110F9E32}"/>
+                <a16:creationId xmlns:a16="http://schemas.microsoft.com/office/drawing/2014/main" id="{EAF4FE12-0148-1BE5-4E10-34BCA013F397}"/>
               </a:ext>
             </a:extLst>
           </p:cNvPr>
@@ -4814,7 +4814,7 @@
           <a:bodyPr/>
           <a:lstStyle/>
           <a:p>
-            <a:fld id="{CAA8DFD1-E9DF-4CED-B539-E78C2BF12841}" type="slidenum">
+            <a:fld id="{FD1A6613-956C-45BA-BE1E-3C432AF7978A}" type="slidenum">
               <a:rPr lang="zh-CN" altLang="en-US" smtClean="0"/>
               <a:t>‹#›</a:t>
             </a:fld>
@@ -4825,7 +4825,7 @@
     </p:spTree>
     <p:extLst>
       <p:ext uri="{BB962C8B-B14F-4D97-AF65-F5344CB8AC3E}">
-        <p14:creationId xmlns:p14="http://schemas.microsoft.com/office/powerpoint/2010/main" val="3724903210"/>
+        <p14:creationId xmlns:p14="http://schemas.microsoft.com/office/powerpoint/2010/main" val="1797065071"/>
       </p:ext>
     </p:extLst>
   </p:cSld>
@@ -4857,7 +4857,7 @@
           <p:cNvPr id="2" name="标题 1">
             <a:extLst>
               <a:ext uri="{FF2B5EF4-FFF2-40B4-BE49-F238E27FC236}">
-                <a16:creationId xmlns:a16="http://schemas.microsoft.com/office/drawing/2014/main" id="{49C4CEFF-DC02-813D-6A69-8D222DDDCF81}"/>
+                <a16:creationId xmlns:a16="http://schemas.microsoft.com/office/drawing/2014/main" id="{71D8FC0D-7BA8-8EFE-D8E2-FCF3364E1D89}"/>
               </a:ext>
             </a:extLst>
           </p:cNvPr>
@@ -4885,7 +4885,7 @@
           <p:cNvPr id="3" name="日期占位符 2">
             <a:extLst>
               <a:ext uri="{FF2B5EF4-FFF2-40B4-BE49-F238E27FC236}">
-                <a16:creationId xmlns:a16="http://schemas.microsoft.com/office/drawing/2014/main" id="{80C9B446-5AFF-718A-742F-AF9F27926CC8}"/>
+                <a16:creationId xmlns:a16="http://schemas.microsoft.com/office/drawing/2014/main" id="{FD2E72AE-3DFC-9C79-9A76-E8459D98923C}"/>
               </a:ext>
             </a:extLst>
           </p:cNvPr>
@@ -4901,9 +4901,9 @@
           <a:bodyPr/>
           <a:lstStyle/>
           <a:p>
-            <a:fld id="{B58E3282-6649-466A-831A-89CC55B996F1}" type="datetimeFigureOut">
+            <a:fld id="{D0201DBD-0E3D-42B7-B956-71A8E5FDA919}" type="datetimeFigureOut">
               <a:rPr lang="zh-CN" altLang="en-US" smtClean="0"/>
-              <a:t>2026/10/25</a:t>
+              <a:t>2026/10/26</a:t>
             </a:fld>
             <a:endParaRPr lang="zh-CN" altLang="en-US"/>
           </a:p>
@@ -4914,7 +4914,7 @@
           <p:cNvPr id="4" name="页脚占位符 3">
             <a:extLst>
               <a:ext uri="{FF2B5EF4-FFF2-40B4-BE49-F238E27FC236}">
-                <a16:creationId xmlns:a16="http://schemas.microsoft.com/office/drawing/2014/main" id="{39C80D50-FB12-95D5-5D44-B5CE19CF3B62}"/>
+                <a16:creationId xmlns:a16="http://schemas.microsoft.com/office/drawing/2014/main" id="{768E0BBC-2B4C-7ADA-FE41-75AD2997AFE9}"/>
               </a:ext>
             </a:extLst>
           </p:cNvPr>
@@ -4939,7 +4939,7 @@
           <p:cNvPr id="5" name="灯片编号占位符 4">
             <a:extLst>
               <a:ext uri="{FF2B5EF4-FFF2-40B4-BE49-F238E27FC236}">
-                <a16:creationId xmlns:a16="http://schemas.microsoft.com/office/drawing/2014/main" id="{C6B49AE5-84D3-51BC-3910-EAD4165BF6E9}"/>
+                <a16:creationId xmlns:a16="http://schemas.microsoft.com/office/drawing/2014/main" id="{A7C8E05D-3CED-8005-0E54-E54DBC03BCE2}"/>
               </a:ext>
             </a:extLst>
           </p:cNvPr>
@@ -4955,7 +4955,7 @@
           <a:bodyPr/>
           <a:lstStyle/>
           <a:p>
-            <a:fld id="{CAA8DFD1-E9DF-4CED-B539-E78C2BF12841}" type="slidenum">
+            <a:fld id="{FD1A6613-956C-45BA-BE1E-3C432AF7978A}" type="slidenum">
               <a:rPr lang="zh-CN" altLang="en-US" smtClean="0"/>
               <a:t>‹#›</a:t>
             </a:fld>
@@ -4966,7 +4966,7 @@
     </p:spTree>
     <p:extLst>
       <p:ext uri="{BB962C8B-B14F-4D97-AF65-F5344CB8AC3E}">
-        <p14:creationId xmlns:p14="http://schemas.microsoft.com/office/powerpoint/2010/main" val="2645827868"/>
+        <p14:creationId xmlns:p14="http://schemas.microsoft.com/office/powerpoint/2010/main" val="1041677878"/>
       </p:ext>
     </p:extLst>
   </p:cSld>
@@ -4998,7 +4998,7 @@
           <p:cNvPr id="2" name="日期占位符 1">
             <a:extLst>
               <a:ext uri="{FF2B5EF4-FFF2-40B4-BE49-F238E27FC236}">
-                <a16:creationId xmlns:a16="http://schemas.microsoft.com/office/drawing/2014/main" id="{8D0CE5D7-F7E6-5418-B3EF-C69FC58D4A57}"/>
+                <a16:creationId xmlns:a16="http://schemas.microsoft.com/office/drawing/2014/main" id="{CDAF0C9C-1BD1-4B46-6892-2DBAD05444EF}"/>
               </a:ext>
             </a:extLst>
           </p:cNvPr>
@@ -5014,9 +5014,9 @@
           <a:bodyPr/>
           <a:lstStyle/>
           <a:p>
-            <a:fld id="{B58E3282-6649-466A-831A-89CC55B996F1}" type="datetimeFigureOut">
+            <a:fld id="{D0201DBD-0E3D-42B7-B956-71A8E5FDA919}" type="datetimeFigureOut">
               <a:rPr lang="zh-CN" altLang="en-US" smtClean="0"/>
-              <a:t>2026/10/25</a:t>
+              <a:t>2026/10/26</a:t>
             </a:fld>
             <a:endParaRPr lang="zh-CN" altLang="en-US"/>
           </a:p>
@@ -5027,7 +5027,7 @@
           <p:cNvPr id="3" name="页脚占位符 2">
             <a:extLst>
               <a:ext uri="{FF2B5EF4-FFF2-40B4-BE49-F238E27FC236}">
-                <a16:creationId xmlns:a16="http://schemas.microsoft.com/office/drawing/2014/main" id="{5B12A9E8-91D6-33C8-2B5A-679D480BE493}"/>
+                <a16:creationId xmlns:a16="http://schemas.microsoft.com/office/drawing/2014/main" id="{4CD59469-0426-DFB6-CBFB-7105A61E2333}"/>
               </a:ext>
             </a:extLst>
           </p:cNvPr>
@@ -5052,7 +5052,7 @@
           <p:cNvPr id="4" name="灯片编号占位符 3">
             <a:extLst>
               <a:ext uri="{FF2B5EF4-FFF2-40B4-BE49-F238E27FC236}">
-                <a16:creationId xmlns:a16="http://schemas.microsoft.com/office/drawing/2014/main" id="{AD2A5AD5-2703-0300-93D9-2F90BF87404C}"/>
+                <a16:creationId xmlns:a16="http://schemas.microsoft.com/office/drawing/2014/main" id="{BB8EE4B6-7CE2-B8DF-546F-A24BA320CB75}"/>
               </a:ext>
             </a:extLst>
           </p:cNvPr>
@@ -5068,7 +5068,7 @@
           <a:bodyPr/>
           <a:lstStyle/>
           <a:p>
-            <a:fld id="{CAA8DFD1-E9DF-4CED-B539-E78C2BF12841}" type="slidenum">
+            <a:fld id="{FD1A6613-956C-45BA-BE1E-3C432AF7978A}" type="slidenum">
               <a:rPr lang="zh-CN" altLang="en-US" smtClean="0"/>
               <a:t>‹#›</a:t>
             </a:fld>
@@ -5079,7 +5079,7 @@
     </p:spTree>
     <p:extLst>
       <p:ext uri="{BB962C8B-B14F-4D97-AF65-F5344CB8AC3E}">
-        <p14:creationId xmlns:p14="http://schemas.microsoft.com/office/powerpoint/2010/main" val="3045999533"/>
+        <p14:creationId xmlns:p14="http://schemas.microsoft.com/office/powerpoint/2010/main" val="2838114434"/>
       </p:ext>
     </p:extLst>
   </p:cSld>
@@ -5111,7 +5111,7 @@
           <p:cNvPr id="2" name="标题 1">
             <a:extLst>
               <a:ext uri="{FF2B5EF4-FFF2-40B4-BE49-F238E27FC236}">
-                <a16:creationId xmlns:a16="http://schemas.microsoft.com/office/drawing/2014/main" id="{90807BAA-AB5B-3C05-8646-94EA99BA26EB}"/>
+                <a16:creationId xmlns:a16="http://schemas.microsoft.com/office/drawing/2014/main" id="{420C49F7-82F4-4F69-90C1-492A68FB3FD9}"/>
               </a:ext>
             </a:extLst>
           </p:cNvPr>
@@ -5148,7 +5148,7 @@
           <p:cNvPr id="3" name="内容占位符 2">
             <a:extLst>
               <a:ext uri="{FF2B5EF4-FFF2-40B4-BE49-F238E27FC236}">
-                <a16:creationId xmlns:a16="http://schemas.microsoft.com/office/drawing/2014/main" id="{626FE124-3AE9-BC6E-9B90-45BEBE71AD6A}"/>
+                <a16:creationId xmlns:a16="http://schemas.microsoft.com/office/drawing/2014/main" id="{120134B4-4B65-9A03-ADD5-C2666DA0E93E}"/>
               </a:ext>
             </a:extLst>
           </p:cNvPr>
@@ -5238,7 +5238,7 @@
           <p:cNvPr id="4" name="文本占位符 3">
             <a:extLst>
               <a:ext uri="{FF2B5EF4-FFF2-40B4-BE49-F238E27FC236}">
-                <a16:creationId xmlns:a16="http://schemas.microsoft.com/office/drawing/2014/main" id="{07FCB64D-100E-0828-9717-9A88975183E0}"/>
+                <a16:creationId xmlns:a16="http://schemas.microsoft.com/office/drawing/2014/main" id="{C8A4159F-F8FE-C475-592A-0D8348FB36F7}"/>
               </a:ext>
             </a:extLst>
           </p:cNvPr>
@@ -5309,7 +5309,7 @@
           <p:cNvPr id="5" name="日期占位符 4">
             <a:extLst>
               <a:ext uri="{FF2B5EF4-FFF2-40B4-BE49-F238E27FC236}">
-                <a16:creationId xmlns:a16="http://schemas.microsoft.com/office/drawing/2014/main" id="{D22900D5-65EE-0D20-C035-73E334A3F98C}"/>
+                <a16:creationId xmlns:a16="http://schemas.microsoft.com/office/drawing/2014/main" id="{11BD4D9E-2B80-83B2-575C-F12FA1DC6764}"/>
               </a:ext>
             </a:extLst>
           </p:cNvPr>
@@ -5325,9 +5325,9 @@
           <a:bodyPr/>
           <a:lstStyle/>
           <a:p>
-            <a:fld id="{B58E3282-6649-466A-831A-89CC55B996F1}" type="datetimeFigureOut">
+            <a:fld id="{D0201DBD-0E3D-42B7-B956-71A8E5FDA919}" type="datetimeFigureOut">
               <a:rPr lang="zh-CN" altLang="en-US" smtClean="0"/>
-              <a:t>2026/10/25</a:t>
+              <a:t>2026/10/26</a:t>
             </a:fld>
             <a:endParaRPr lang="zh-CN" altLang="en-US"/>
           </a:p>
@@ -5338,7 +5338,7 @@
           <p:cNvPr id="6" name="页脚占位符 5">
             <a:extLst>
               <a:ext uri="{FF2B5EF4-FFF2-40B4-BE49-F238E27FC236}">
-                <a16:creationId xmlns:a16="http://schemas.microsoft.com/office/drawing/2014/main" id="{0D6152E3-A601-D4D2-1AF0-4221B7600AAA}"/>
+                <a16:creationId xmlns:a16="http://schemas.microsoft.com/office/drawing/2014/main" id="{6936021A-8BDF-FCBB-DFE2-FE7D00F9FB3A}"/>
               </a:ext>
             </a:extLst>
           </p:cNvPr>
@@ -5363,7 +5363,7 @@
           <p:cNvPr id="7" name="灯片编号占位符 6">
             <a:extLst>
               <a:ext uri="{FF2B5EF4-FFF2-40B4-BE49-F238E27FC236}">
-                <a16:creationId xmlns:a16="http://schemas.microsoft.com/office/drawing/2014/main" id="{E6BC1491-41F6-96BC-6598-0973EE7335DB}"/>
+                <a16:creationId xmlns:a16="http://schemas.microsoft.com/office/drawing/2014/main" id="{40D54AE5-F6DA-1F4C-20CB-C7465027B8FE}"/>
               </a:ext>
             </a:extLst>
           </p:cNvPr>
@@ -5379,7 +5379,7 @@
           <a:bodyPr/>
           <a:lstStyle/>
           <a:p>
-            <a:fld id="{CAA8DFD1-E9DF-4CED-B539-E78C2BF12841}" type="slidenum">
+            <a:fld id="{FD1A6613-956C-45BA-BE1E-3C432AF7978A}" type="slidenum">
               <a:rPr lang="zh-CN" altLang="en-US" smtClean="0"/>
               <a:t>‹#›</a:t>
             </a:fld>
@@ -5390,7 +5390,7 @@
     </p:spTree>
     <p:extLst>
       <p:ext uri="{BB962C8B-B14F-4D97-AF65-F5344CB8AC3E}">
-        <p14:creationId xmlns:p14="http://schemas.microsoft.com/office/powerpoint/2010/main" val="3090418294"/>
+        <p14:creationId xmlns:p14="http://schemas.microsoft.com/office/powerpoint/2010/main" val="3016426221"/>
       </p:ext>
     </p:extLst>
   </p:cSld>
@@ -5422,7 +5422,7 @@
           <p:cNvPr id="2" name="标题 1">
             <a:extLst>
               <a:ext uri="{FF2B5EF4-FFF2-40B4-BE49-F238E27FC236}">
-                <a16:creationId xmlns:a16="http://schemas.microsoft.com/office/drawing/2014/main" id="{3292A620-8250-018C-58EE-730B3B1FE6D9}"/>
+                <a16:creationId xmlns:a16="http://schemas.microsoft.com/office/drawing/2014/main" id="{13321D84-D031-BD40-DD9B-9AAF93360173}"/>
               </a:ext>
             </a:extLst>
           </p:cNvPr>
@@ -5459,7 +5459,7 @@
           <p:cNvPr id="3" name="图片占位符 2">
             <a:extLst>
               <a:ext uri="{FF2B5EF4-FFF2-40B4-BE49-F238E27FC236}">
-                <a16:creationId xmlns:a16="http://schemas.microsoft.com/office/drawing/2014/main" id="{E59CCC33-F107-4808-D712-DB168CCA4F4D}"/>
+                <a16:creationId xmlns:a16="http://schemas.microsoft.com/office/drawing/2014/main" id="{2FDA7559-5798-2314-EE3F-1D640E4523B3}"/>
               </a:ext>
             </a:extLst>
           </p:cNvPr>
@@ -5526,7 +5526,7 @@
           <p:cNvPr id="4" name="文本占位符 3">
             <a:extLst>
               <a:ext uri="{FF2B5EF4-FFF2-40B4-BE49-F238E27FC236}">
-                <a16:creationId xmlns:a16="http://schemas.microsoft.com/office/drawing/2014/main" id="{0187572A-5F76-3454-D570-412E7BDB970F}"/>
+                <a16:creationId xmlns:a16="http://schemas.microsoft.com/office/drawing/2014/main" id="{3FA580D7-F1AA-E4B1-5724-CFC264F49172}"/>
               </a:ext>
             </a:extLst>
           </p:cNvPr>
@@ -5597,7 +5597,7 @@
           <p:cNvPr id="5" name="日期占位符 4">
             <a:extLst>
               <a:ext uri="{FF2B5EF4-FFF2-40B4-BE49-F238E27FC236}">
-                <a16:creationId xmlns:a16="http://schemas.microsoft.com/office/drawing/2014/main" id="{ED004C7B-DC27-3E1A-C243-8288E675A213}"/>
+                <a16:creationId xmlns:a16="http://schemas.microsoft.com/office/drawing/2014/main" id="{EB8DFEA2-F286-41CF-6CA4-52399C0DD6BC}"/>
               </a:ext>
             </a:extLst>
           </p:cNvPr>
@@ -5613,9 +5613,9 @@
           <a:bodyPr/>
           <a:lstStyle/>
           <a:p>
-            <a:fld id="{B58E3282-6649-466A-831A-89CC55B996F1}" type="datetimeFigureOut">
+            <a:fld id="{D0201DBD-0E3D-42B7-B956-71A8E5FDA919}" type="datetimeFigureOut">
               <a:rPr lang="zh-CN" altLang="en-US" smtClean="0"/>
-              <a:t>2026/10/25</a:t>
+              <a:t>2026/10/26</a:t>
             </a:fld>
             <a:endParaRPr lang="zh-CN" altLang="en-US"/>
           </a:p>
@@ -5626,7 +5626,7 @@
           <p:cNvPr id="6" name="页脚占位符 5">
             <a:extLst>
               <a:ext uri="{FF2B5EF4-FFF2-40B4-BE49-F238E27FC236}">
-                <a16:creationId xmlns:a16="http://schemas.microsoft.com/office/drawing/2014/main" id="{9CE228F0-205A-75CF-8552-4416A6DC71E1}"/>
+                <a16:creationId xmlns:a16="http://schemas.microsoft.com/office/drawing/2014/main" id="{00DC6DC7-6018-0B83-9E5E-105F96D953DE}"/>
               </a:ext>
             </a:extLst>
           </p:cNvPr>
@@ -5651,7 +5651,7 @@
           <p:cNvPr id="7" name="灯片编号占位符 6">
             <a:extLst>
               <a:ext uri="{FF2B5EF4-FFF2-40B4-BE49-F238E27FC236}">
-                <a16:creationId xmlns:a16="http://schemas.microsoft.com/office/drawing/2014/main" id="{CD2A74AD-B6C1-AD43-3B25-9337491EC386}"/>
+                <a16:creationId xmlns:a16="http://schemas.microsoft.com/office/drawing/2014/main" id="{6002B730-423D-1570-6A64-6C14D32C4304}"/>
               </a:ext>
             </a:extLst>
           </p:cNvPr>
@@ -5667,7 +5667,7 @@
           <a:bodyPr/>
           <a:lstStyle/>
           <a:p>
-            <a:fld id="{CAA8DFD1-E9DF-4CED-B539-E78C2BF12841}" type="slidenum">
+            <a:fld id="{FD1A6613-956C-45BA-BE1E-3C432AF7978A}" type="slidenum">
               <a:rPr lang="zh-CN" altLang="en-US" smtClean="0"/>
               <a:t>‹#›</a:t>
             </a:fld>
@@ -5678,7 +5678,7 @@
     </p:spTree>
     <p:extLst>
       <p:ext uri="{BB962C8B-B14F-4D97-AF65-F5344CB8AC3E}">
-        <p14:creationId xmlns:p14="http://schemas.microsoft.com/office/powerpoint/2010/main" val="1803005249"/>
+        <p14:creationId xmlns:p14="http://schemas.microsoft.com/office/powerpoint/2010/main" val="2340235561"/>
       </p:ext>
     </p:extLst>
   </p:cSld>
@@ -5715,7 +5715,7 @@
           <p:cNvPr id="2" name="标题占位符 1">
             <a:extLst>
               <a:ext uri="{FF2B5EF4-FFF2-40B4-BE49-F238E27FC236}">
-                <a16:creationId xmlns:a16="http://schemas.microsoft.com/office/drawing/2014/main" id="{DC86B15C-4B3E-7653-B2F6-2820E62FFE01}"/>
+                <a16:creationId xmlns:a16="http://schemas.microsoft.com/office/drawing/2014/main" id="{B0FE0139-DD63-783A-6D3C-934F5D736333}"/>
               </a:ext>
             </a:extLst>
           </p:cNvPr>
@@ -5753,7 +5753,7 @@
           <p:cNvPr id="3" name="文本占位符 2">
             <a:extLst>
               <a:ext uri="{FF2B5EF4-FFF2-40B4-BE49-F238E27FC236}">
-                <a16:creationId xmlns:a16="http://schemas.microsoft.com/office/drawing/2014/main" id="{C036B753-E72E-341C-1F4C-652DB4DFB01E}"/>
+                <a16:creationId xmlns:a16="http://schemas.microsoft.com/office/drawing/2014/main" id="{3A99101A-B717-BA31-A337-F7B14C230D9E}"/>
               </a:ext>
             </a:extLst>
           </p:cNvPr>
@@ -5820,7 +5820,7 @@
           <p:cNvPr id="4" name="日期占位符 3">
             <a:extLst>
               <a:ext uri="{FF2B5EF4-FFF2-40B4-BE49-F238E27FC236}">
-                <a16:creationId xmlns:a16="http://schemas.microsoft.com/office/drawing/2014/main" id="{C1A81DF8-EF8B-8FEE-481E-89F8D7455A16}"/>
+                <a16:creationId xmlns:a16="http://schemas.microsoft.com/office/drawing/2014/main" id="{B269E827-D189-988F-8790-6EC56DC344E7}"/>
               </a:ext>
             </a:extLst>
           </p:cNvPr>
@@ -5854,9 +5854,9 @@
             </a:lvl1pPr>
           </a:lstStyle>
           <a:p>
-            <a:fld id="{B58E3282-6649-466A-831A-89CC55B996F1}" type="datetimeFigureOut">
+            <a:fld id="{D0201DBD-0E3D-42B7-B956-71A8E5FDA919}" type="datetimeFigureOut">
               <a:rPr lang="zh-CN" altLang="en-US" smtClean="0"/>
-              <a:t>2026/10/25</a:t>
+              <a:t>2026/10/26</a:t>
             </a:fld>
             <a:endParaRPr lang="zh-CN" altLang="en-US"/>
           </a:p>
@@ -5867,7 +5867,7 @@
           <p:cNvPr id="5" name="页脚占位符 4">
             <a:extLst>
               <a:ext uri="{FF2B5EF4-FFF2-40B4-BE49-F238E27FC236}">
-                <a16:creationId xmlns:a16="http://schemas.microsoft.com/office/drawing/2014/main" id="{62CB7894-38E0-2027-7916-81775102E237}"/>
+                <a16:creationId xmlns:a16="http://schemas.microsoft.com/office/drawing/2014/main" id="{258533F7-F3A7-CB2A-3102-7B93EF34D1D7}"/>
               </a:ext>
             </a:extLst>
           </p:cNvPr>
@@ -5910,7 +5910,7 @@
           <p:cNvPr id="6" name="灯片编号占位符 5">
             <a:extLst>
               <a:ext uri="{FF2B5EF4-FFF2-40B4-BE49-F238E27FC236}">
-                <a16:creationId xmlns:a16="http://schemas.microsoft.com/office/drawing/2014/main" id="{6BE719BF-D92C-274A-A57A-D54A35C87153}"/>
+                <a16:creationId xmlns:a16="http://schemas.microsoft.com/office/drawing/2014/main" id="{DBB0928A-86D7-453C-37EF-386BA152E9AA}"/>
               </a:ext>
             </a:extLst>
           </p:cNvPr>
@@ -5944,7 +5944,7 @@
             </a:lvl1pPr>
           </a:lstStyle>
           <a:p>
-            <a:fld id="{CAA8DFD1-E9DF-4CED-B539-E78C2BF12841}" type="slidenum">
+            <a:fld id="{FD1A6613-956C-45BA-BE1E-3C432AF7978A}" type="slidenum">
               <a:rPr lang="zh-CN" altLang="en-US" smtClean="0"/>
               <a:t>‹#›</a:t>
             </a:fld>
@@ -5955,7 +5955,7 @@
     </p:spTree>
     <p:extLst>
       <p:ext uri="{BB962C8B-B14F-4D97-AF65-F5344CB8AC3E}">
-        <p14:creationId xmlns:p14="http://schemas.microsoft.com/office/powerpoint/2010/main" val="257805990"/>
+        <p14:creationId xmlns:p14="http://schemas.microsoft.com/office/powerpoint/2010/main" val="611325939"/>
       </p:ext>
     </p:extLst>
   </p:cSld>
@@ -6278,7 +6278,7 @@
           <p:cNvPr id="3" name="图片 2">
             <a:extLst>
               <a:ext uri="{FF2B5EF4-FFF2-40B4-BE49-F238E27FC236}">
-                <a16:creationId xmlns:a16="http://schemas.microsoft.com/office/drawing/2014/main" id="{3829E95A-3A5B-472C-8CD2-E45659B0B985}"/>
+                <a16:creationId xmlns:a16="http://schemas.microsoft.com/office/drawing/2014/main" id="{7989E3FD-AFB8-9AC1-ED34-24F383DA52C5}"/>
               </a:ext>
             </a:extLst>
           </p:cNvPr>
@@ -6312,7 +6312,7 @@
     </p:spTree>
     <p:extLst>
       <p:ext uri="{BB962C8B-B14F-4D97-AF65-F5344CB8AC3E}">
-        <p14:creationId xmlns:p14="http://schemas.microsoft.com/office/powerpoint/2010/main" val="1748461989"/>
+        <p14:creationId xmlns:p14="http://schemas.microsoft.com/office/powerpoint/2010/main" val="4096756170"/>
       </p:ext>
     </p:extLst>
   </p:cSld>
@@ -6344,7 +6344,7 @@
           <p:cNvPr id="3" name="图片 2">
             <a:extLst>
               <a:ext uri="{FF2B5EF4-FFF2-40B4-BE49-F238E27FC236}">
-                <a16:creationId xmlns:a16="http://schemas.microsoft.com/office/drawing/2014/main" id="{A5DC256D-F8EB-F1C9-2D9F-4D165327D1E0}"/>
+                <a16:creationId xmlns:a16="http://schemas.microsoft.com/office/drawing/2014/main" id="{C4EA9A3E-4D07-7E4C-27C3-F331286DD91E}"/>
               </a:ext>
             </a:extLst>
           </p:cNvPr>
@@ -6378,7 +6378,7 @@
     </p:spTree>
     <p:extLst>
       <p:ext uri="{BB962C8B-B14F-4D97-AF65-F5344CB8AC3E}">
-        <p14:creationId xmlns:p14="http://schemas.microsoft.com/office/powerpoint/2010/main" val="4203038224"/>
+        <p14:creationId xmlns:p14="http://schemas.microsoft.com/office/powerpoint/2010/main" val="784650823"/>
       </p:ext>
     </p:extLst>
   </p:cSld>
@@ -6410,7 +6410,7 @@
           <p:cNvPr id="3" name="图片 2">
             <a:extLst>
               <a:ext uri="{FF2B5EF4-FFF2-40B4-BE49-F238E27FC236}">
-                <a16:creationId xmlns:a16="http://schemas.microsoft.com/office/drawing/2014/main" id="{485CA9B9-6EB6-E965-23BB-F626AD60B5DC}"/>
+                <a16:creationId xmlns:a16="http://schemas.microsoft.com/office/drawing/2014/main" id="{7AD35874-395F-0526-95B8-EEA8FB5BC43D}"/>
               </a:ext>
             </a:extLst>
           </p:cNvPr>
@@ -6444,7 +6444,7 @@
     </p:spTree>
     <p:extLst>
       <p:ext uri="{BB962C8B-B14F-4D97-AF65-F5344CB8AC3E}">
-        <p14:creationId xmlns:p14="http://schemas.microsoft.com/office/powerpoint/2010/main" val="2314844289"/>
+        <p14:creationId xmlns:p14="http://schemas.microsoft.com/office/powerpoint/2010/main" val="1661427931"/>
       </p:ext>
     </p:extLst>
   </p:cSld>
@@ -6476,7 +6476,7 @@
           <p:cNvPr id="3" name="图片 2">
             <a:extLst>
               <a:ext uri="{FF2B5EF4-FFF2-40B4-BE49-F238E27FC236}">
-                <a16:creationId xmlns:a16="http://schemas.microsoft.com/office/drawing/2014/main" id="{773914E6-F61D-1045-5267-D5048EF42AF3}"/>
+                <a16:creationId xmlns:a16="http://schemas.microsoft.com/office/drawing/2014/main" id="{E94C866E-9B90-8FCF-60DF-BC60F1EA738C}"/>
               </a:ext>
             </a:extLst>
           </p:cNvPr>
@@ -6510,7 +6510,7 @@
     </p:spTree>
     <p:extLst>
       <p:ext uri="{BB962C8B-B14F-4D97-AF65-F5344CB8AC3E}">
-        <p14:creationId xmlns:p14="http://schemas.microsoft.com/office/powerpoint/2010/main" val="3060120566"/>
+        <p14:creationId xmlns:p14="http://schemas.microsoft.com/office/powerpoint/2010/main" val="1248377740"/>
       </p:ext>
     </p:extLst>
   </p:cSld>
@@ -6542,7 +6542,7 @@
           <p:cNvPr id="3" name="图片 2">
             <a:extLst>
               <a:ext uri="{FF2B5EF4-FFF2-40B4-BE49-F238E27FC236}">
-                <a16:creationId xmlns:a16="http://schemas.microsoft.com/office/drawing/2014/main" id="{046D2CB4-42DE-F505-D31C-1F9DE861EA4E}"/>
+                <a16:creationId xmlns:a16="http://schemas.microsoft.com/office/drawing/2014/main" id="{4D1DD095-3D2D-8ED7-6B0F-F9F315870018}"/>
               </a:ext>
             </a:extLst>
           </p:cNvPr>
@@ -6576,7 +6576,7 @@
     </p:spTree>
     <p:extLst>
       <p:ext uri="{BB962C8B-B14F-4D97-AF65-F5344CB8AC3E}">
-        <p14:creationId xmlns:p14="http://schemas.microsoft.com/office/powerpoint/2010/main" val="3362161765"/>
+        <p14:creationId xmlns:p14="http://schemas.microsoft.com/office/powerpoint/2010/main" val="989966717"/>
       </p:ext>
     </p:extLst>
   </p:cSld>
@@ -6608,7 +6608,7 @@
           <p:cNvPr id="3" name="图片 2">
             <a:extLst>
               <a:ext uri="{FF2B5EF4-FFF2-40B4-BE49-F238E27FC236}">
-                <a16:creationId xmlns:a16="http://schemas.microsoft.com/office/drawing/2014/main" id="{DACCAF3E-493D-E076-80ED-6D04CEF4592A}"/>
+                <a16:creationId xmlns:a16="http://schemas.microsoft.com/office/drawing/2014/main" id="{80EF6AED-4F3E-52DD-ABCF-415489599E1F}"/>
               </a:ext>
             </a:extLst>
           </p:cNvPr>
@@ -6642,7 +6642,7 @@
     </p:spTree>
     <p:extLst>
       <p:ext uri="{BB962C8B-B14F-4D97-AF65-F5344CB8AC3E}">
-        <p14:creationId xmlns:p14="http://schemas.microsoft.com/office/powerpoint/2010/main" val="3525985955"/>
+        <p14:creationId xmlns:p14="http://schemas.microsoft.com/office/powerpoint/2010/main" val="2054977570"/>
       </p:ext>
     </p:extLst>
   </p:cSld>
@@ -6674,7 +6674,7 @@
           <p:cNvPr id="3" name="图片 2">
             <a:extLst>
               <a:ext uri="{FF2B5EF4-FFF2-40B4-BE49-F238E27FC236}">
-                <a16:creationId xmlns:a16="http://schemas.microsoft.com/office/drawing/2014/main" id="{4A77C5B5-B7A1-4D0A-A5DB-45E42218AE7F}"/>
+                <a16:creationId xmlns:a16="http://schemas.microsoft.com/office/drawing/2014/main" id="{A7719F28-EC03-4E5B-4B38-FDDDCA23EBC9}"/>
               </a:ext>
             </a:extLst>
           </p:cNvPr>
@@ -6708,7 +6708,7 @@
     </p:spTree>
     <p:extLst>
       <p:ext uri="{BB962C8B-B14F-4D97-AF65-F5344CB8AC3E}">
-        <p14:creationId xmlns:p14="http://schemas.microsoft.com/office/powerpoint/2010/main" val="3153849372"/>
+        <p14:creationId xmlns:p14="http://schemas.microsoft.com/office/powerpoint/2010/main" val="1623665329"/>
       </p:ext>
     </p:extLst>
   </p:cSld>
@@ -6740,7 +6740,7 @@
           <p:cNvPr id="3" name="图片 2">
             <a:extLst>
               <a:ext uri="{FF2B5EF4-FFF2-40B4-BE49-F238E27FC236}">
-                <a16:creationId xmlns:a16="http://schemas.microsoft.com/office/drawing/2014/main" id="{9B04DD0A-A8C9-D955-9D57-FEAAC0A7FAEE}"/>
+                <a16:creationId xmlns:a16="http://schemas.microsoft.com/office/drawing/2014/main" id="{43067917-0E14-6D39-D2C5-4729EC97A226}"/>
               </a:ext>
             </a:extLst>
           </p:cNvPr>
@@ -6774,7 +6774,7 @@
     </p:spTree>
     <p:extLst>
       <p:ext uri="{BB962C8B-B14F-4D97-AF65-F5344CB8AC3E}">
-        <p14:creationId xmlns:p14="http://schemas.microsoft.com/office/powerpoint/2010/main" val="3682370100"/>
+        <p14:creationId xmlns:p14="http://schemas.microsoft.com/office/powerpoint/2010/main" val="2157535942"/>
       </p:ext>
     </p:extLst>
   </p:cSld>
@@ -6806,7 +6806,7 @@
           <p:cNvPr id="3" name="图片 2">
             <a:extLst>
               <a:ext uri="{FF2B5EF4-FFF2-40B4-BE49-F238E27FC236}">
-                <a16:creationId xmlns:a16="http://schemas.microsoft.com/office/drawing/2014/main" id="{ADDCEA7F-BA79-2207-C34F-26696F307CEE}"/>
+                <a16:creationId xmlns:a16="http://schemas.microsoft.com/office/drawing/2014/main" id="{5ED17151-48DD-8288-750F-256EC93CA3C6}"/>
               </a:ext>
             </a:extLst>
           </p:cNvPr>
@@ -6840,7 +6840,7 @@
     </p:spTree>
     <p:extLst>
       <p:ext uri="{BB962C8B-B14F-4D97-AF65-F5344CB8AC3E}">
-        <p14:creationId xmlns:p14="http://schemas.microsoft.com/office/powerpoint/2010/main" val="2069694692"/>
+        <p14:creationId xmlns:p14="http://schemas.microsoft.com/office/powerpoint/2010/main" val="2187136673"/>
       </p:ext>
     </p:extLst>
   </p:cSld>
@@ -6872,7 +6872,7 @@
           <p:cNvPr id="3" name="图片 2">
             <a:extLst>
               <a:ext uri="{FF2B5EF4-FFF2-40B4-BE49-F238E27FC236}">
-                <a16:creationId xmlns:a16="http://schemas.microsoft.com/office/drawing/2014/main" id="{0629C2AA-E50B-2790-4C22-7484A3290EAF}"/>
+                <a16:creationId xmlns:a16="http://schemas.microsoft.com/office/drawing/2014/main" id="{3073C401-30AD-677F-EB9A-82C93546C879}"/>
               </a:ext>
             </a:extLst>
           </p:cNvPr>
@@ -6903,10 +6903,81 @@
           </a:prstGeom>
         </p:spPr>
       </p:pic>
+      <p:sp>
+        <p:nvSpPr>
+          <p:cNvPr id="4" name="link: https://r1s1226.github.io/email-eu-core-sna/">
+            <a:hlinkClick r:id="rId4"/>
+            <a:extLst>
+              <a:ext uri="{FF2B5EF4-FFF2-40B4-BE49-F238E27FC236}">
+                <a16:creationId xmlns:a16="http://schemas.microsoft.com/office/drawing/2014/main" id="{1BE5CA2A-2A9F-67C6-227C-CD3FA8248B8D}"/>
+              </a:ext>
+            </a:extLst>
+          </p:cNvPr>
+          <p:cNvSpPr/>
+          <p:nvPr/>
+        </p:nvSpPr>
+        <p:spPr>
+          <a:xfrm>
+            <a:off x="1612900" y="5232400"/>
+            <a:ext cx="4102100" cy="317500"/>
+          </a:xfrm>
+          <a:prstGeom prst="rect">
+            <a:avLst/>
+          </a:prstGeom>
+          <a:solidFill>
+            <a:srgbClr val="000000">
+              <a:alpha val="0"/>
+            </a:srgbClr>
+          </a:solidFill>
+          <a:ln w="19050" cap="flat" cmpd="sng" algn="ctr">
+            <a:noFill/>
+            <a:prstDash val="solid"/>
+            <a:miter lim="800000"/>
+          </a:ln>
+          <a:effectLst/>
+          <a:extLst>
+            <a:ext uri="{91240B29-F687-4F45-9708-019B960494DF}">
+              <a14:hiddenLine xmlns:a14="http://schemas.microsoft.com/office/drawing/2010/main" w="19050" cap="flat" cmpd="sng" algn="ctr">
+                <a:solidFill>
+                  <a:schemeClr val="accent1">
+                    <a:shade val="15000"/>
+                  </a:schemeClr>
+                </a:solidFill>
+                <a:prstDash val="solid"/>
+                <a:miter lim="800000"/>
+              </a14:hiddenLine>
+            </a:ext>
+          </a:extLst>
+        </p:spPr>
+        <p:style>
+          <a:lnRef idx="2">
+            <a:schemeClr val="accent1">
+              <a:shade val="15000"/>
+            </a:schemeClr>
+          </a:lnRef>
+          <a:fillRef idx="1">
+            <a:schemeClr val="accent1"/>
+          </a:fillRef>
+          <a:effectRef idx="0">
+            <a:schemeClr val="accent1"/>
+          </a:effectRef>
+          <a:fontRef idx="minor">
+            <a:schemeClr val="lt1"/>
+          </a:fontRef>
+        </p:style>
+        <p:txBody>
+          <a:bodyPr rtlCol="0" anchor="ctr"/>
+          <a:lstStyle/>
+          <a:p>
+            <a:pPr algn="ctr"/>
+            <a:endParaRPr lang="zh-CN" altLang="en-US"/>
+          </a:p>
+        </p:txBody>
+      </p:sp>
     </p:spTree>
     <p:extLst>
       <p:ext uri="{BB962C8B-B14F-4D97-AF65-F5344CB8AC3E}">
-        <p14:creationId xmlns:p14="http://schemas.microsoft.com/office/powerpoint/2010/main" val="346443495"/>
+        <p14:creationId xmlns:p14="http://schemas.microsoft.com/office/powerpoint/2010/main" val="2597273302"/>
       </p:ext>
     </p:extLst>
   </p:cSld>
@@ -6938,7 +7009,7 @@
           <p:cNvPr id="3" name="图片 2">
             <a:extLst>
               <a:ext uri="{FF2B5EF4-FFF2-40B4-BE49-F238E27FC236}">
-                <a16:creationId xmlns:a16="http://schemas.microsoft.com/office/drawing/2014/main" id="{6D4785F2-774B-FCB5-660A-73E0ABA5D060}"/>
+                <a16:creationId xmlns:a16="http://schemas.microsoft.com/office/drawing/2014/main" id="{EC37C261-5519-CA82-2D38-52A6231AFE27}"/>
               </a:ext>
             </a:extLst>
           </p:cNvPr>
@@ -6972,7 +7043,7 @@
     </p:spTree>
     <p:extLst>
       <p:ext uri="{BB962C8B-B14F-4D97-AF65-F5344CB8AC3E}">
-        <p14:creationId xmlns:p14="http://schemas.microsoft.com/office/powerpoint/2010/main" val="546811083"/>
+        <p14:creationId xmlns:p14="http://schemas.microsoft.com/office/powerpoint/2010/main" val="2291501063"/>
       </p:ext>
     </p:extLst>
   </p:cSld>

</xml_diff>